<commit_message>
cleaned up scripts (moved to tests/legacy and tests/experimental) and solved R CMD checks failing
</commit_message>
<xml_diff>
--- a/inst/assets/logos.pptx
+++ b/inst/assets/logos.pptx
@@ -7,6 +7,7 @@
   <p:sldIdLst>
     <p:sldId id="256" r:id="rId2"/>
     <p:sldId id="257" r:id="rId3"/>
+    <p:sldId id="258" r:id="rId4"/>
   </p:sldIdLst>
   <p:sldSz cx="12192000" cy="6858000"/>
   <p:notesSz cx="6858000" cy="9144000"/>
@@ -105,6 +106,11 @@
       </a:defRPr>
     </a:lvl9pPr>
   </p:defaultTextStyle>
+  <p:extLst>
+    <p:ext uri="{EFAFB233-063F-42B5-8137-9DF3F51BA10A}">
+      <p15:sldGuideLst xmlns:p15="http://schemas.microsoft.com/office/powerpoint/2012/main"/>
+    </p:ext>
+  </p:extLst>
 </p:presentation>
 </file>
 
@@ -255,7 +261,7 @@
           <a:p>
             <a:fld id="{EF5F43FF-496F-7243-9466-E2A5DF3D9D13}" type="datetimeFigureOut">
               <a:rPr lang="en-US" smtClean="0"/>
-              <a:t>6/2/24</a:t>
+              <a:t>9/23/26</a:t>
             </a:fld>
             <a:endParaRPr lang="en-US"/>
           </a:p>
@@ -453,7 +459,7 @@
           <a:p>
             <a:fld id="{EF5F43FF-496F-7243-9466-E2A5DF3D9D13}" type="datetimeFigureOut">
               <a:rPr lang="en-US" smtClean="0"/>
-              <a:t>6/2/24</a:t>
+              <a:t>9/23/26</a:t>
             </a:fld>
             <a:endParaRPr lang="en-US"/>
           </a:p>
@@ -661,7 +667,7 @@
           <a:p>
             <a:fld id="{EF5F43FF-496F-7243-9466-E2A5DF3D9D13}" type="datetimeFigureOut">
               <a:rPr lang="en-US" smtClean="0"/>
-              <a:t>6/2/24</a:t>
+              <a:t>9/23/26</a:t>
             </a:fld>
             <a:endParaRPr lang="en-US"/>
           </a:p>
@@ -859,7 +865,7 @@
           <a:p>
             <a:fld id="{EF5F43FF-496F-7243-9466-E2A5DF3D9D13}" type="datetimeFigureOut">
               <a:rPr lang="en-US" smtClean="0"/>
-              <a:t>6/2/24</a:t>
+              <a:t>9/23/26</a:t>
             </a:fld>
             <a:endParaRPr lang="en-US"/>
           </a:p>
@@ -1134,7 +1140,7 @@
           <a:p>
             <a:fld id="{EF5F43FF-496F-7243-9466-E2A5DF3D9D13}" type="datetimeFigureOut">
               <a:rPr lang="en-US" smtClean="0"/>
-              <a:t>6/2/24</a:t>
+              <a:t>9/23/26</a:t>
             </a:fld>
             <a:endParaRPr lang="en-US"/>
           </a:p>
@@ -1399,7 +1405,7 @@
           <a:p>
             <a:fld id="{EF5F43FF-496F-7243-9466-E2A5DF3D9D13}" type="datetimeFigureOut">
               <a:rPr lang="en-US" smtClean="0"/>
-              <a:t>6/2/24</a:t>
+              <a:t>9/23/26</a:t>
             </a:fld>
             <a:endParaRPr lang="en-US"/>
           </a:p>
@@ -1811,7 +1817,7 @@
           <a:p>
             <a:fld id="{EF5F43FF-496F-7243-9466-E2A5DF3D9D13}" type="datetimeFigureOut">
               <a:rPr lang="en-US" smtClean="0"/>
-              <a:t>6/2/24</a:t>
+              <a:t>9/23/26</a:t>
             </a:fld>
             <a:endParaRPr lang="en-US"/>
           </a:p>
@@ -1952,7 +1958,7 @@
           <a:p>
             <a:fld id="{EF5F43FF-496F-7243-9466-E2A5DF3D9D13}" type="datetimeFigureOut">
               <a:rPr lang="en-US" smtClean="0"/>
-              <a:t>6/2/24</a:t>
+              <a:t>9/23/26</a:t>
             </a:fld>
             <a:endParaRPr lang="en-US"/>
           </a:p>
@@ -2065,7 +2071,7 @@
           <a:p>
             <a:fld id="{EF5F43FF-496F-7243-9466-E2A5DF3D9D13}" type="datetimeFigureOut">
               <a:rPr lang="en-US" smtClean="0"/>
-              <a:t>6/2/24</a:t>
+              <a:t>9/23/26</a:t>
             </a:fld>
             <a:endParaRPr lang="en-US"/>
           </a:p>
@@ -2376,7 +2382,7 @@
           <a:p>
             <a:fld id="{EF5F43FF-496F-7243-9466-E2A5DF3D9D13}" type="datetimeFigureOut">
               <a:rPr lang="en-US" smtClean="0"/>
-              <a:t>6/2/24</a:t>
+              <a:t>9/23/26</a:t>
             </a:fld>
             <a:endParaRPr lang="en-US"/>
           </a:p>
@@ -2664,7 +2670,7 @@
           <a:p>
             <a:fld id="{EF5F43FF-496F-7243-9466-E2A5DF3D9D13}" type="datetimeFigureOut">
               <a:rPr lang="en-US" smtClean="0"/>
-              <a:t>6/2/24</a:t>
+              <a:t>9/23/26</a:t>
             </a:fld>
             <a:endParaRPr lang="en-US"/>
           </a:p>
@@ -2905,7 +2911,7 @@
           <a:p>
             <a:fld id="{EF5F43FF-496F-7243-9466-E2A5DF3D9D13}" type="datetimeFigureOut">
               <a:rPr lang="en-US" smtClean="0"/>
-              <a:t>6/2/24</a:t>
+              <a:t>9/23/26</a:t>
             </a:fld>
             <a:endParaRPr lang="en-US"/>
           </a:p>
@@ -3817,6 +3823,184 @@
     <p:extLst>
       <p:ext uri="{BB962C8B-B14F-4D97-AF65-F5344CB8AC3E}">
         <p14:creationId xmlns:p14="http://schemas.microsoft.com/office/powerpoint/2010/main" val="861024459"/>
+      </p:ext>
+    </p:extLst>
+  </p:cSld>
+  <p:clrMapOvr>
+    <a:masterClrMapping/>
+  </p:clrMapOvr>
+</p:sld>
+</file>
+
+<file path=ppt/slides/slide3.xml><?xml version="1.0" encoding="utf-8"?>
+<p:sld xmlns:a="http://schemas.openxmlformats.org/drawingml/2006/main" xmlns:r="http://schemas.openxmlformats.org/officeDocument/2006/relationships" xmlns:p="http://schemas.openxmlformats.org/presentationml/2006/main">
+  <p:cSld>
+    <p:spTree>
+      <p:nvGrpSpPr>
+        <p:cNvPr id="1" name=""/>
+        <p:cNvGrpSpPr/>
+        <p:nvPr/>
+      </p:nvGrpSpPr>
+      <p:grpSpPr>
+        <a:xfrm>
+          <a:off x="0" y="0"/>
+          <a:ext cx="0" cy="0"/>
+          <a:chOff x="0" y="0"/>
+          <a:chExt cx="0" cy="0"/>
+        </a:xfrm>
+      </p:grpSpPr>
+      <p:sp>
+        <p:nvSpPr>
+          <p:cNvPr id="2" name="Title 1">
+            <a:extLst>
+              <a:ext uri="{FF2B5EF4-FFF2-40B4-BE49-F238E27FC236}">
+                <a16:creationId xmlns:a16="http://schemas.microsoft.com/office/drawing/2014/main" id="{1AA627C0-5D61-186C-6AAF-C4198FDD2594}"/>
+              </a:ext>
+            </a:extLst>
+          </p:cNvPr>
+          <p:cNvSpPr>
+            <a:spLocks noGrp="1"/>
+          </p:cNvSpPr>
+          <p:nvPr>
+            <p:ph type="title"/>
+          </p:nvPr>
+        </p:nvSpPr>
+        <p:spPr/>
+        <p:txBody>
+          <a:bodyPr/>
+          <a:lstStyle/>
+          <a:p>
+            <a:endParaRPr lang="en-US" dirty="0"/>
+          </a:p>
+        </p:txBody>
+      </p:sp>
+      <p:pic>
+        <p:nvPicPr>
+          <p:cNvPr id="5" name="Content Placeholder 4">
+            <a:extLst>
+              <a:ext uri="{FF2B5EF4-FFF2-40B4-BE49-F238E27FC236}">
+                <a16:creationId xmlns:a16="http://schemas.microsoft.com/office/drawing/2014/main" id="{8427A2D9-99A4-513B-2822-7879BFC630BC}"/>
+              </a:ext>
+            </a:extLst>
+          </p:cNvPr>
+          <p:cNvPicPr>
+            <a:picLocks noGrp="1" noChangeAspect="1"/>
+          </p:cNvPicPr>
+          <p:nvPr>
+            <p:ph idx="1"/>
+          </p:nvPr>
+        </p:nvPicPr>
+        <p:blipFill>
+          <a:blip r:embed="rId2"/>
+          <a:stretch>
+            <a:fillRect/>
+          </a:stretch>
+        </p:blipFill>
+        <p:spPr>
+          <a:xfrm>
+            <a:off x="1239761" y="1975937"/>
+            <a:ext cx="4351338" cy="4351338"/>
+          </a:xfrm>
+          <a:prstGeom prst="rect">
+            <a:avLst/>
+          </a:prstGeom>
+        </p:spPr>
+      </p:pic>
+      <p:pic>
+        <p:nvPicPr>
+          <p:cNvPr id="6" name="Content Placeholder 4">
+            <a:extLst>
+              <a:ext uri="{FF2B5EF4-FFF2-40B4-BE49-F238E27FC236}">
+                <a16:creationId xmlns:a16="http://schemas.microsoft.com/office/drawing/2014/main" id="{2BD53EB9-F4E1-ECAF-0129-B07B41232B22}"/>
+              </a:ext>
+            </a:extLst>
+          </p:cNvPr>
+          <p:cNvPicPr>
+            <a:picLocks noChangeAspect="1"/>
+          </p:cNvPicPr>
+          <p:nvPr/>
+        </p:nvPicPr>
+        <p:blipFill>
+          <a:blip r:embed="rId3" cstate="screen">
+            <a:extLst>
+              <a:ext uri="{28A0092B-C50C-407E-A947-70E740481C1C}">
+                <a14:useLocalDpi xmlns:a14="http://schemas.microsoft.com/office/drawing/2010/main"/>
+              </a:ext>
+            </a:extLst>
+          </a:blip>
+          <a:stretch>
+            <a:fillRect/>
+          </a:stretch>
+        </p:blipFill>
+        <p:spPr>
+          <a:xfrm>
+            <a:off x="6364993" y="1897649"/>
+            <a:ext cx="4351338" cy="4351338"/>
+          </a:xfrm>
+          <a:prstGeom prst="rect">
+            <a:avLst/>
+          </a:prstGeom>
+        </p:spPr>
+      </p:pic>
+      <p:sp>
+        <p:nvSpPr>
+          <p:cNvPr id="7" name="Donut 6">
+            <a:extLst>
+              <a:ext uri="{FF2B5EF4-FFF2-40B4-BE49-F238E27FC236}">
+                <a16:creationId xmlns:a16="http://schemas.microsoft.com/office/drawing/2014/main" id="{46A485CA-E4B4-BF1D-420F-0163B8D2EA39}"/>
+              </a:ext>
+            </a:extLst>
+          </p:cNvPr>
+          <p:cNvSpPr/>
+          <p:nvPr/>
+        </p:nvSpPr>
+        <p:spPr>
+          <a:xfrm>
+            <a:off x="6364993" y="1897649"/>
+            <a:ext cx="4351337" cy="4351338"/>
+          </a:xfrm>
+          <a:prstGeom prst="donut">
+            <a:avLst>
+              <a:gd name="adj" fmla="val 5433"/>
+            </a:avLst>
+          </a:prstGeom>
+          <a:ln>
+            <a:solidFill>
+              <a:schemeClr val="bg1"/>
+            </a:solidFill>
+          </a:ln>
+        </p:spPr>
+        <p:style>
+          <a:lnRef idx="2">
+            <a:schemeClr val="accent6"/>
+          </a:lnRef>
+          <a:fillRef idx="1">
+            <a:schemeClr val="lt1"/>
+          </a:fillRef>
+          <a:effectRef idx="0">
+            <a:schemeClr val="accent6"/>
+          </a:effectRef>
+          <a:fontRef idx="minor">
+            <a:schemeClr val="dk1"/>
+          </a:fontRef>
+        </p:style>
+        <p:txBody>
+          <a:bodyPr rtlCol="0" anchor="ctr"/>
+          <a:lstStyle/>
+          <a:p>
+            <a:pPr algn="ctr"/>
+            <a:endParaRPr lang="en-US">
+              <a:solidFill>
+                <a:schemeClr val="tx1"/>
+              </a:solidFill>
+            </a:endParaRPr>
+          </a:p>
+        </p:txBody>
+      </p:sp>
+    </p:spTree>
+    <p:extLst>
+      <p:ext uri="{BB962C8B-B14F-4D97-AF65-F5344CB8AC3E}">
+        <p14:creationId xmlns:p14="http://schemas.microsoft.com/office/powerpoint/2010/main" val="3541495790"/>
       </p:ext>
     </p:extLst>
   </p:cSld>

</xml_diff>